<commit_message>
Catégories de produits pour P&V, Qonto, SNCF
Co-Authored-By: Claude Opus 5.5 <noreply@anthropic.com>
Claude-Session: https://claude.ai/code/session_01BmxtdWjbeRUyPx9e1qVLbT
</commit_message>
<xml_diff>
--- a/rapports/septembre/Pierre_et_Vacances_sept2026.pptx
+++ b/rapports/septembre/Pierre_et_Vacances_sept2026.pptx
@@ -5879,7 +5879,7 @@
                 </a:solidFill>
                 <a:latin typeface="Arial"/>
               </a:rPr>
-              <a:t>MARQUES CITÉES</a:t>
+              <a:t>CATÉGORIES DE PRODUITS</a:t>
             </a:r>
           </a:p>
         </p:txBody>
@@ -5914,7 +5914,7 @@
                 </a:solidFill>
                 <a:latin typeface="Arial"/>
               </a:rPr>
-              <a:t>Part de voix dans les messages utilisateurs</a:t>
+              <a:t>Répartition des requêtes</a:t>
             </a:r>
           </a:p>
         </p:txBody>
@@ -6022,13 +6022,13 @@
           <a:p>
             <a:pPr algn="l"/>
             <a:r>
-              <a:rPr sz="1000" b="0" i="0">
+              <a:rPr sz="800" b="0" i="0">
                 <a:solidFill>
                   <a:srgbClr val="111111"/>
                 </a:solidFill>
                 <a:latin typeface="Arial"/>
               </a:rPr>
-              <a:t>Airbnb</a:t>
+              <a:t>Résidences et appartements de vacances</a:t>
             </a:r>
           </a:p>
         </p:txBody>
@@ -6107,7 +6107,7 @@
                 </a:solidFill>
                 <a:latin typeface="Arial"/>
               </a:rPr>
-              <a:t>Booking · 17 %</a:t>
+              <a:t>Villages et clubs · 20 %</a:t>
             </a:r>
           </a:p>
         </p:txBody>
@@ -6186,7 +6186,7 @@
                 </a:solidFill>
                 <a:latin typeface="Arial"/>
               </a:rPr>
-              <a:t>Gîtes de France · 11 %</a:t>
+              <a:t>Séjours montagne et ski · 16 %</a:t>
             </a:r>
           </a:p>
         </p:txBody>
@@ -6265,7 +6265,7 @@
                 </a:solidFill>
                 <a:latin typeface="Arial"/>
               </a:rPr>
-              <a:t>Abritel · 7 %</a:t>
+              <a:t>Séjours mer et littoral · 14 %</a:t>
             </a:r>
           </a:p>
         </p:txBody>
@@ -6344,7 +6344,7 @@
                 </a:solidFill>
                 <a:latin typeface="Arial"/>
               </a:rPr>
-              <a:t>Pierre &amp; Vacances · 5 %</a:t>
+              <a:t>Week-ends et courts séjours · 8 %</a:t>
             </a:r>
           </a:p>
         </p:txBody>
@@ -6423,7 +6423,7 @@
                 </a:solidFill>
                 <a:latin typeface="Arial"/>
               </a:rPr>
-              <a:t>Autres · 35 %</a:t>
+              <a:t>Bien-être et activités · 4 %</a:t>
             </a:r>
           </a:p>
         </p:txBody>
@@ -6437,7 +6437,7 @@
         <p:spPr>
           <a:xfrm>
             <a:off x="10564368" y="4450080"/>
-            <a:ext cx="475488" cy="335280"/>
+            <a:ext cx="475488" cy="509625"/>
           </a:xfrm>
           <a:prstGeom prst="rect">
             <a:avLst/>
@@ -6481,7 +6481,7 @@
         <p:spPr>
           <a:xfrm>
             <a:off x="10564368" y="4450080"/>
-            <a:ext cx="475488" cy="335280"/>
+            <a:ext cx="475488" cy="509625"/>
           </a:xfrm>
           <a:prstGeom prst="rect">
             <a:avLst/>
@@ -6502,7 +6502,7 @@
                 </a:solidFill>
                 <a:latin typeface="Arial"/>
               </a:rPr>
-              <a:t>25 %</a:t>
+              <a:t>38 %</a:t>
             </a:r>
           </a:p>
         </p:txBody>
@@ -6515,8 +6515,8 @@
         </p:nvSpPr>
         <p:spPr>
           <a:xfrm>
-            <a:off x="10564368" y="4785360"/>
-            <a:ext cx="475488" cy="227990"/>
+            <a:off x="10564368" y="4959705"/>
+            <a:ext cx="475488" cy="268224"/>
           </a:xfrm>
           <a:prstGeom prst="rect">
             <a:avLst/>
@@ -6559,8 +6559,8 @@
         </p:nvSpPr>
         <p:spPr>
           <a:xfrm>
-            <a:off x="10564368" y="5013350"/>
-            <a:ext cx="475488" cy="147523"/>
+            <a:off x="10564368" y="5227929"/>
+            <a:ext cx="475488" cy="214579"/>
           </a:xfrm>
           <a:prstGeom prst="rect">
             <a:avLst/>
@@ -6603,8 +6603,8 @@
         </p:nvSpPr>
         <p:spPr>
           <a:xfrm>
-            <a:off x="10564368" y="5160873"/>
-            <a:ext cx="475488" cy="93878"/>
+            <a:off x="10564368" y="5442508"/>
+            <a:ext cx="475488" cy="187756"/>
           </a:xfrm>
           <a:prstGeom prst="rect">
             <a:avLst/>
@@ -6647,8 +6647,8 @@
         </p:nvSpPr>
         <p:spPr>
           <a:xfrm>
-            <a:off x="10564368" y="5254752"/>
-            <a:ext cx="475488" cy="67056"/>
+            <a:off x="10564368" y="5630265"/>
+            <a:ext cx="475488" cy="107289"/>
           </a:xfrm>
           <a:prstGeom prst="rect">
             <a:avLst/>
@@ -6691,8 +6691,8 @@
         </p:nvSpPr>
         <p:spPr>
           <a:xfrm>
-            <a:off x="10564368" y="5321808"/>
-            <a:ext cx="475488" cy="469392"/>
+            <a:off x="10564368" y="5737555"/>
+            <a:ext cx="475488" cy="53644"/>
           </a:xfrm>
           <a:prstGeom prst="rect">
             <a:avLst/>
@@ -6724,41 +6724,6 @@
           <a:lstStyle/>
           <a:p>
             <a:pPr algn="ctr"/>
-          </a:p>
-        </p:txBody>
-      </p:sp>
-      <p:sp>
-        <p:nvSpPr>
-          <p:cNvPr id="93" name="TextBox 92"/>
-          <p:cNvSpPr txBox="1"/>
-          <p:nvPr/>
-        </p:nvSpPr>
-        <p:spPr>
-          <a:xfrm>
-            <a:off x="10564368" y="5321808"/>
-            <a:ext cx="475488" cy="469392"/>
-          </a:xfrm>
-          <a:prstGeom prst="rect">
-            <a:avLst/>
-          </a:prstGeom>
-          <a:noFill/>
-        </p:spPr>
-        <p:txBody>
-          <a:bodyPr wrap="square" anchor="ctr" lIns="0" rIns="0" tIns="0" bIns="0">
-            <a:spAutoFit/>
-          </a:bodyPr>
-          <a:lstStyle/>
-          <a:p>
-            <a:pPr algn="ctr"/>
-            <a:r>
-              <a:rPr sz="1000" b="1" i="0">
-                <a:solidFill>
-                  <a:srgbClr val="FFFFFF"/>
-                </a:solidFill>
-                <a:latin typeface="Arial"/>
-              </a:rPr>
-              <a:t>35 %</a:t>
-            </a:r>
           </a:p>
         </p:txBody>
       </p:sp>

</xml_diff>